<commit_message>
Default slurm mode to interactive; per-phase tcsh and sh job scripts
- slurm.mode defaults to interactive (srun); --wait implies batch
- Each phase gets <phase>.csh (tcsh) and <phase>.sh (sh) holding its
  pre_phase, phase and post_phase commands; run.csh / run.sh run the
  phases in order. job_shell (config) or --shell picks the set to run;
  per-step .cmd files are removed
- Local runs execute the same run script as slurm, with a Python
  fallback when the shell is not installed
- Sample project moved to example/; default config falls back to it
- README, session.md, user guide and training deck updated

Co-Authored-By: Claude Opus 5.5 <noreply@anthropic.com>
</commit_message>
<xml_diff>
--- a/doc/dv_flow_training.pptx
+++ b/doc/dv_flow_training.pptx
@@ -138,13 +138,13 @@
   <p:extLst>
     <p:ext uri="{521415D9-36F7-43E2-AB2F-B90AF26B5E84}">
       <p14:sectionLst xmlns:p14="http://schemas.microsoft.com/office/powerpoint/2010/main">
-        <p14:section name="Introduction" id="{124bd649-f218-1ada-ecd2-a043a5dcd5b4}">
+        <p14:section name="Introduction" id="{d36f8a0c-8e75-6ab7-5104-41e6affd84df}">
           <p14:sldIdLst>
             <p14:sldId id="256"/>
             <p14:sldId id="257"/>
           </p14:sldIdLst>
         </p14:section>
-        <p14:section name="Concepts" id="{443552df-c1d1-a733-26e9-5ef24e10082b}">
+        <p14:section name="Concepts" id="{fb52c6db-05fd-7272-7c4c-d133d8385308}">
           <p14:sldIdLst>
             <p14:sldId id="258"/>
             <p14:sldId id="259"/>
@@ -154,7 +154,7 @@
             <p14:sldId id="263"/>
           </p14:sldIdLst>
         </p14:section>
-        <p14:section name="Running the flow" id="{cbdffb2e-cea1-6dcc-7b02-5fed91e6f446}">
+        <p14:section name="Running the flow" id="{1484c84f-18a1-956d-1b64-defc8c98fb01}">
           <p14:sldIdLst>
             <p14:sldId id="264"/>
             <p14:sldId id="265"/>
@@ -163,7 +163,7 @@
             <p14:sldId id="268"/>
           </p14:sldIdLst>
         </p14:section>
-        <p14:section name="Advanced configuration" id="{17af4edb-3ac3-25fb-8b7d-1d56070f1976}">
+        <p14:section name="Advanced configuration" id="{fbef3e61-d48b-4a47-cdd5-c3c20949ff80}">
           <p14:sldIdLst>
             <p14:sldId id="269"/>
             <p14:sldId id="270"/>
@@ -173,7 +173,7 @@
             <p14:sldId id="274"/>
           </p14:sldIdLst>
         </p14:section>
-        <p14:section name="Slurm" id="{1a3af61b-31d1-40fe-8996-dc78a0dc2524}">
+        <p14:section name="Slurm" id="{3b9a8619-393d-3188-e834-650c946691db}">
           <p14:sldIdLst>
             <p14:sldId id="275"/>
             <p14:sldId id="276"/>
@@ -183,7 +183,7 @@
             <p14:sldId id="280"/>
           </p14:sldIdLst>
         </p14:section>
-        <p14:section name="Debugging and tips" id="{0acf76d3-1717-68ed-468a-07bb63ceaf09}">
+        <p14:section name="Debugging and tips" id="{dac525a4-9e6b-ec90-0d29-d8e6a55a9080}">
           <p14:sldIdLst>
             <p14:sldId id="281"/>
             <p14:sldId id="282"/>
@@ -1742,7 +1742,7 @@
           <a:p>
             <a:r>
               <a:rPr lang="en-US" dirty="0"/>
-              <a:t>Batch for regressions, interactive for debugging and GUI sessions. --slurm turns Slurm on; slurm.enable makes it the default.</a:t>
+              <a:t>Interactive is the default: --slurm alone runs srun in your terminal. For regressions use batch, with --mode=batch or --wait, which implies batch. slurm.enable makes Slurm the default; slurm.mode changes the default mode.</a:t>
             </a:r>
             <a:endParaRPr lang="en-US" dirty="0"/>
           </a:p>
@@ -2006,7 +2006,7 @@
           <a:p>
             <a:r>
               <a:rPr lang="en-US" dirty="0"/>
-              <a:t>Default one hour per test job. Slurm enforces the limit: SIGTERM, a grace period, then SIGKILL. run.sh records the kill; the tracker asks Slurm when it cannot.</a:t>
+              <a:t>Default one hour per test job. Slurm enforces the limit: SIGTERM, a grace period, then SIGKILL. tcsh cannot trap SIGTERM, so the tracker asks Slurm with sacct; the sh scripts record the kill themselves.</a:t>
             </a:r>
             <a:endParaRPr lang="en-US" dirty="0"/>
           </a:p>
@@ -2270,7 +2270,7 @@
           <a:p>
             <a:r>
               <a:rPr lang="en-US" dirty="0"/>
-              <a:t>Work from the outside in: what the flow planned, then the job directory, then the failing step. Re-running a .cmd file reproduces exactly what the flow ran.</a:t>
+              <a:t>Work from the outside in: what the flow planned, then the job directory, then the failing step. Re-running a phase script reproduces exactly what the flow ran.</a:t>
             </a:r>
             <a:endParaRPr lang="en-US" dirty="0"/>
           </a:p>
@@ -3238,7 +3238,7 @@
           <a:p>
             <a:r>
               <a:rPr lang="en-US" dirty="0"/>
-              <a:t>Every job has its own directory with run.sh, one .cmd and .log per step, and status files. This is where you debug.</a:t>
+              <a:t>Every job has its own directory. Each phase gets one tcsh script and one sh script with its pre, main and post commands; run.csh runs the phases. One log per step, and status files. This is where you debug.</a:t>
             </a:r>
             <a:endParaRPr lang="en-US" dirty="0"/>
           </a:p>
@@ -12529,7 +12529,7 @@
                   <a:schemeClr val="tx1"/>
                 </a:solidFill>
               </a:rPr>
-              <a:t>Use --slurm --mode=interactive --gui</a:t>
+              <a:t>Use --slurm --gui (interactive)</a:t>
             </a:r>
             <a:endParaRPr lang="en-US" sz="1300" dirty="0"/>
           </a:p>
@@ -14862,7 +14862,7 @@
                   <a:schemeClr val="tx2"/>
                 </a:solidFill>
               </a:rPr>
-              <a:t>Batch or interactive</a:t>
+              <a:t>Interactive or batch</a:t>
             </a:r>
             <a:endParaRPr lang="en-US" sz="3000" dirty="0"/>
           </a:p>
@@ -14870,7 +14870,7 @@
       </p:sp>
       <p:sp>
         <p:nvSpPr>
-          <p:cNvPr id="4" name="mode batch"/>
+          <p:cNvPr id="4" name="mode interactive"/>
           <p:cNvSpPr/>
           <p:nvPr/>
         </p:nvSpPr>
@@ -14904,7 +14904,7 @@
       </p:sp>
       <p:sp>
         <p:nvSpPr>
-          <p:cNvPr id="5" name="mode title batch"/>
+          <p:cNvPr id="5" name="mode title interactive"/>
           <p:cNvSpPr txBox="1"/>
           <p:nvPr/>
         </p:nvSpPr>
@@ -14932,7 +14932,7 @@
                   <a:schemeClr val="tx2"/>
                 </a:solidFill>
               </a:rPr>
-              <a:t>batch</a:t>
+              <a:t>interactive</a:t>
             </a:r>
             <a:pPr indent="0" marL="0">
               <a:buNone/>
@@ -14946,7 +14946,7 @@
                 <a:ea typeface="Courier New" pitchFamily="34" charset="-122"/>
                 <a:cs typeface="Courier New" pitchFamily="34" charset="-120"/>
               </a:rPr>
-              <a:t>   sbatch</a:t>
+              <a:t>   srun --pty</a:t>
             </a:r>
             <a:endParaRPr lang="en-US" sz="1800" dirty="0"/>
           </a:p>
@@ -14954,7 +14954,7 @@
       </p:sp>
       <p:sp>
         <p:nvSpPr>
-          <p:cNvPr id="6" name="mode list batch"/>
+          <p:cNvPr id="6" name="mode list interactive"/>
           <p:cNvSpPr txBox="1"/>
           <p:nvPr/>
         </p:nvSpPr>
@@ -14986,7 +14986,7 @@
                   <a:schemeClr val="tx1"/>
                 </a:solidFill>
               </a:rPr>
-              <a:t>All jobs submitted at once, run in parallel</a:t>
+              <a:t>Default mode: --slurm alone</a:t>
             </a:r>
             <a:endParaRPr lang="en-US" sz="1300" dirty="0"/>
           </a:p>
@@ -15004,7 +15004,7 @@
                   <a:schemeClr val="tx1"/>
                 </a:solidFill>
               </a:rPr>
-              <a:t>Tests wait for the build (afterok)</a:t>
+              <a:t>One job at a time in your terminal</a:t>
             </a:r>
             <a:endParaRPr lang="en-US" sz="1300" dirty="0"/>
           </a:p>
@@ -15022,7 +15022,7 @@
                   <a:schemeClr val="tx1"/>
                 </a:solidFill>
               </a:rPr>
-              <a:t>--wait to block until results</a:t>
+              <a:t>Use with --gui (X11)</a:t>
             </a:r>
             <a:endParaRPr lang="en-US" sz="1300" dirty="0"/>
           </a:p>
@@ -15040,7 +15040,7 @@
                   <a:schemeClr val="tx1"/>
                 </a:solidFill>
               </a:rPr>
-              <a:t>Manifest saved for --track</a:t>
+              <a:t>Good for debugging one test</a:t>
             </a:r>
             <a:endParaRPr lang="en-US" sz="1300" dirty="0"/>
           </a:p>
@@ -15048,7 +15048,7 @@
       </p:sp>
       <p:sp>
         <p:nvSpPr>
-          <p:cNvPr id="7" name="mode code batch"/>
+          <p:cNvPr id="7" name="mode code interactive"/>
           <p:cNvSpPr/>
           <p:nvPr/>
         </p:nvSpPr>
@@ -15075,7 +15075,7 @@
       </p:sp>
       <p:sp>
         <p:nvSpPr>
-          <p:cNvPr id="8" name="mode code batch text"/>
+          <p:cNvPr id="8" name="mode code interactive text"/>
           <p:cNvSpPr txBox="1"/>
           <p:nvPr/>
         </p:nvSpPr>
@@ -15106,15 +15106,32 @@
                 <a:ea typeface="Courier New" pitchFamily="34" charset="-122"/>
                 <a:cs typeface="Courier New" pitchFamily="34" charset="-120"/>
               </a:rPr>
-              <a:t>--testcase=regression --slurm --wait</a:t>
+              <a:t>--phase=sim --testcase=smoke \</a:t>
             </a:r>
             <a:endParaRPr lang="en-US" sz="1000" dirty="0"/>
           </a:p>
-        </p:txBody>
-      </p:sp>
-      <p:sp>
-        <p:nvSpPr>
-          <p:cNvPr id="9" name="mode interactive"/>
+          <a:p>
+            <a:pPr indent="0" marL="0">
+              <a:buNone/>
+            </a:pPr>
+            <a:r>
+              <a:rPr lang="en-US" sz="1000" dirty="0">
+                <a:solidFill>
+                  <a:schemeClr val="bg2"/>
+                </a:solidFill>
+                <a:latin typeface="Courier New" pitchFamily="34" charset="0"/>
+                <a:ea typeface="Courier New" pitchFamily="34" charset="-122"/>
+                <a:cs typeface="Courier New" pitchFamily="34" charset="-120"/>
+              </a:rPr>
+              <a:t>  --slurm --gui</a:t>
+            </a:r>
+            <a:endParaRPr lang="en-US" sz="1000" dirty="0"/>
+          </a:p>
+        </p:txBody>
+      </p:sp>
+      <p:sp>
+        <p:nvSpPr>
+          <p:cNvPr id="9" name="mode batch"/>
           <p:cNvSpPr/>
           <p:nvPr/>
         </p:nvSpPr>
@@ -15148,7 +15165,7 @@
       </p:sp>
       <p:sp>
         <p:nvSpPr>
-          <p:cNvPr id="10" name="mode title interactive"/>
+          <p:cNvPr id="10" name="mode title batch"/>
           <p:cNvSpPr txBox="1"/>
           <p:nvPr/>
         </p:nvSpPr>
@@ -15176,7 +15193,7 @@
                   <a:schemeClr val="tx2"/>
                 </a:solidFill>
               </a:rPr>
-              <a:t>interactive</a:t>
+              <a:t>batch</a:t>
             </a:r>
             <a:pPr indent="0" marL="0">
               <a:buNone/>
@@ -15190,7 +15207,7 @@
                 <a:ea typeface="Courier New" pitchFamily="34" charset="-122"/>
                 <a:cs typeface="Courier New" pitchFamily="34" charset="-120"/>
               </a:rPr>
-              <a:t>   srun --pty</a:t>
+              <a:t>   sbatch</a:t>
             </a:r>
             <a:endParaRPr lang="en-US" sz="1800" dirty="0"/>
           </a:p>
@@ -15198,7 +15215,7 @@
       </p:sp>
       <p:sp>
         <p:nvSpPr>
-          <p:cNvPr id="11" name="mode list interactive"/>
+          <p:cNvPr id="11" name="mode list batch"/>
           <p:cNvSpPr txBox="1"/>
           <p:nvPr/>
         </p:nvSpPr>
@@ -15230,7 +15247,7 @@
                   <a:schemeClr val="tx1"/>
                 </a:solidFill>
               </a:rPr>
-              <a:t>One job at a time in your terminal</a:t>
+              <a:t>All jobs submitted at once, run in parallel</a:t>
             </a:r>
             <a:endParaRPr lang="en-US" sz="1300" dirty="0"/>
           </a:p>
@@ -15248,7 +15265,7 @@
                   <a:schemeClr val="tx1"/>
                 </a:solidFill>
               </a:rPr>
-              <a:t>dv_flow waits for each job</a:t>
+              <a:t>Tests wait for the build (afterok)</a:t>
             </a:r>
             <a:endParaRPr lang="en-US" sz="1300" dirty="0"/>
           </a:p>
@@ -15266,7 +15283,7 @@
                   <a:schemeClr val="tx1"/>
                 </a:solidFill>
               </a:rPr>
-              <a:t>Use with --gui (X11)</a:t>
+              <a:t>--mode=batch, or --wait to block</a:t>
             </a:r>
             <a:endParaRPr lang="en-US" sz="1300" dirty="0"/>
           </a:p>
@@ -15284,7 +15301,7 @@
                   <a:schemeClr val="tx1"/>
                 </a:solidFill>
               </a:rPr>
-              <a:t>Good for debugging one test</a:t>
+              <a:t>Manifest saved for --track</a:t>
             </a:r>
             <a:endParaRPr lang="en-US" sz="1300" dirty="0"/>
           </a:p>
@@ -15292,7 +15309,7 @@
       </p:sp>
       <p:sp>
         <p:nvSpPr>
-          <p:cNvPr id="12" name="mode code interactive"/>
+          <p:cNvPr id="12" name="mode code batch"/>
           <p:cNvSpPr/>
           <p:nvPr/>
         </p:nvSpPr>
@@ -15319,7 +15336,7 @@
       </p:sp>
       <p:sp>
         <p:nvSpPr>
-          <p:cNvPr id="13" name="mode code interactive text"/>
+          <p:cNvPr id="13" name="mode code batch text"/>
           <p:cNvSpPr txBox="1"/>
           <p:nvPr/>
         </p:nvSpPr>
@@ -15350,24 +15367,7 @@
                 <a:ea typeface="Courier New" pitchFamily="34" charset="-122"/>
                 <a:cs typeface="Courier New" pitchFamily="34" charset="-120"/>
               </a:rPr>
-              <a:t>--phase=sim --testcase=smoke --slurm \</a:t>
-            </a:r>
-            <a:endParaRPr lang="en-US" sz="1000" dirty="0"/>
-          </a:p>
-          <a:p>
-            <a:pPr indent="0" marL="0">
-              <a:buNone/>
-            </a:pPr>
-            <a:r>
-              <a:rPr lang="en-US" sz="1000" dirty="0">
-                <a:solidFill>
-                  <a:schemeClr val="bg2"/>
-                </a:solidFill>
-                <a:latin typeface="Courier New" pitchFamily="34" charset="0"/>
-                <a:ea typeface="Courier New" pitchFamily="34" charset="-122"/>
-                <a:cs typeface="Courier New" pitchFamily="34" charset="-120"/>
-              </a:rPr>
-              <a:t>  --mode=interactive --gui</a:t>
+              <a:t>--testcase=regression --slurm --wait</a:t>
             </a:r>
             <a:endParaRPr lang="en-US" sz="1000" dirty="0"/>
           </a:p>
@@ -15609,7 +15609,7 @@
                 <a:ea typeface="Courier New" pitchFamily="34" charset="-122"/>
                 <a:cs typeface="Courier New" pitchFamily="34" charset="-120"/>
               </a:rPr>
-              <a:t>  out/dut_a/tests/smoke.1/run.sh</a:t>
+              <a:t>  out/dut_a/tests/smoke.1/run.csh</a:t>
             </a:r>
             <a:endParaRPr lang="en-US" sz="1200" dirty="0"/>
           </a:p>
@@ -19689,7 +19689,7 @@
                   <a:schemeClr val="tx1"/>
                 </a:solidFill>
               </a:rPr>
-              <a:t>bash sim.phase.cmd: re-run one step</a:t>
+              <a:t>tcsh -f sim.csh: re-run one phase</a:t>
             </a:r>
             <a:endParaRPr lang="en-US" sz="1400" dirty="0"/>
           </a:p>
@@ -19786,7 +19786,7 @@
                   <a:schemeClr val="tx1"/>
                 </a:solidFill>
               </a:rPr>
-              <a:t>bash run.sh: re-run the whole job</a:t>
+              <a:t>tcsh -f run.csh: re-run the job</a:t>
             </a:r>
             <a:endParaRPr lang="en-US" sz="1400" dirty="0"/>
           </a:p>
@@ -19983,7 +19983,7 @@
                 <a:ea typeface="Courier New" pitchFamily="34" charset="-122"/>
                 <a:cs typeface="Courier New" pitchFamily="34" charset="-120"/>
               </a:rPr>
-              <a:t>bash sim.phase.cmd</a:t>
+              <a:t>tcsh -f sim.csh</a:t>
             </a:r>
             <a:endParaRPr lang="en-US" sz="1100" dirty="0"/>
           </a:p>
@@ -22821,7 +22821,7 @@
                   <a:schemeClr val="tx1"/>
                 </a:solidFill>
               </a:rPr>
-              <a:t>Run demo; open run.sh, .cmd, dv_flow.status</a:t>
+              <a:t>Run demo; open run.csh, sim.csh, dv_flow.status</a:t>
             </a:r>
             <a:endParaRPr lang="en-US" sz="1200" dirty="0"/>
           </a:p>
@@ -26188,7 +26188,7 @@
                   <a:schemeClr val="accent6"/>
                 </a:solidFill>
               </a:rPr>
-              <a:t>run.sh, *.cmd</a:t>
+              <a:t>&lt;phase&gt;.csh/.sh</a:t>
             </a:r>
             <a:endParaRPr lang="en-US" sz="1100" dirty="0"/>
           </a:p>
@@ -28963,7 +28963,7 @@
                 <a:ea typeface="Courier New" pitchFamily="34" charset="-122"/>
                 <a:cs typeface="Courier New" pitchFamily="34" charset="-120"/>
               </a:rPr>
-              <a:t>        run.sh</a:t>
+              <a:t>        run.csh  run.sh</a:t>
             </a:r>
             <a:endParaRPr lang="en-US" sz="1100" dirty="0"/>
           </a:p>
@@ -28980,7 +28980,7 @@
                 <a:ea typeface="Courier New" pitchFamily="34" charset="-122"/>
                 <a:cs typeface="Courier New" pitchFamily="34" charset="-120"/>
               </a:rPr>
-              <a:t>        sim.phase.cmd</a:t>
+              <a:t>        sim.csh  sim.sh</a:t>
             </a:r>
             <a:endParaRPr lang="en-US" sz="1100" dirty="0"/>
           </a:p>
@@ -29256,7 +29256,7 @@
                           <a:ea typeface="Courier New" pitchFamily="34" charset="-122"/>
                           <a:cs typeface="Courier New" pitchFamily="34" charset="-120"/>
                         </a:rPr>
-                        <a:t>run.sh</a:t>
+                        <a:t>&lt;phase&gt;.csh / .sh</a:t>
                       </a:r>
                       <a:endParaRPr lang="en-US" sz="1100" dirty="0">
                         <a:latin typeface="Courier New" charset="0"/>
@@ -29321,7 +29321,7 @@
                             <a:schemeClr val="tx1"/>
                           </a:solidFill>
                         </a:rPr>
-                        <a:t>The whole job - Slurm runs this</a:t>
+                        <a:t>One phase: pre, main, post; re-run with tcsh -f</a:t>
                       </a:r>
                       <a:endParaRPr lang="en-US" sz="1100" dirty="0"/>
                     </a:p>
@@ -29387,7 +29387,7 @@
                           <a:ea typeface="Courier New" pitchFamily="34" charset="-122"/>
                           <a:cs typeface="Courier New" pitchFamily="34" charset="-120"/>
                         </a:rPr>
-                        <a:t>&lt;phase&gt;.&lt;step&gt;.cmd</a:t>
+                        <a:t>run.csh / run.sh</a:t>
                       </a:r>
                       <a:endParaRPr lang="en-US" sz="1100" dirty="0">
                         <a:latin typeface="Courier New" charset="0"/>
@@ -29452,7 +29452,7 @@
                             <a:schemeClr val="tx1"/>
                           </a:solidFill>
                         </a:rPr>
-                        <a:t>Exact command of one step; re-run with bash</a:t>
+                        <a:t>The whole job - Slurm runs run.csh</a:t>
                       </a:r>
                       <a:endParaRPr lang="en-US" sz="1100" dirty="0"/>
                     </a:p>

</xml_diff>